<commit_message>
test: update audit evidence and synthetic fixtures
Update verification audit reports, documentation timestamps, and NCR source identity fixtures to reflect current system state and ensure test reproducibility.
</commit_message>
<xml_diff>
--- a/evidence/certification/StructuSight-NCR-Verification.pptx
+++ b/evidence/certification/StructuSight-NCR-Verification.pptx
@@ -5023,7 +5023,7 @@
                 <a:ea typeface="Arial" pitchFamily="34" charset="-122"/>
                 <a:cs typeface="Arial" pitchFamily="34" charset="-120"/>
               </a:rPr>
-              <a:t>[StructuSight NCR Remediation Verification]  |  Document Control Enterprise Report  |  Generated: 11 October 2026</a:t>
+              <a:t>[StructuSight NCR Remediation Verification]  |  Document Control Enterprise Report  |  Generated: 12 October 2026</a:t>
             </a:r>
             <a:endParaRPr lang="en-US" sz="750" dirty="0"/>
           </a:p>
@@ -6177,7 +6177,7 @@
                 <a:ea typeface="Arial" pitchFamily="34" charset="-122"/>
                 <a:cs typeface="Arial" pitchFamily="34" charset="-120"/>
               </a:rPr>
-              <a:t>Report Date: October 11, 2026</a:t>
+              <a:t>Report Date: October 12, 2026</a:t>
             </a:r>
             <a:endParaRPr lang="en-US" sz="1300" dirty="0"/>
           </a:p>
@@ -9103,7 +9103,7 @@
                             <a:srgbClr val="BE123C"/>
                           </a:solidFill>
                         </a:rPr>
-                        <a:t>125 days</a:t>
+                        <a:t>126 days</a:t>
                       </a:r>
                       <a:endParaRPr lang="en-US" sz="750" dirty="0"/>
                     </a:p>
@@ -10634,7 +10634,7 @@
                             <a:srgbClr val="0F172A"/>
                           </a:solidFill>
                         </a:rPr>
-                        <a:t>5</a:t>
+                        <a:t>4</a:t>
                       </a:r>
                       <a:endParaRPr lang="en-US" sz="900" dirty="0"/>
                     </a:p>
@@ -10817,7 +10817,7 @@
                             <a:srgbClr val="92400E"/>
                           </a:solidFill>
                         </a:rPr>
-                        <a:t>2</a:t>
+                        <a:t>1</a:t>
                       </a:r>
                       <a:endParaRPr lang="en-US" sz="900" dirty="0"/>
                     </a:p>
@@ -10878,7 +10878,7 @@
                             <a:srgbClr val="1E3A8A"/>
                           </a:solidFill>
                         </a:rPr>
-                        <a:t>4</a:t>
+                        <a:t>3</a:t>
                       </a:r>
                       <a:endParaRPr lang="en-US" sz="900" dirty="0"/>
                     </a:p>
@@ -11122,7 +11122,7 @@
                             <a:srgbClr val="D97706"/>
                           </a:solidFill>
                         </a:rPr>
-                        <a:t>2</a:t>
+                        <a:t>1</a:t>
                       </a:r>
                       <a:endParaRPr lang="en-US" sz="900" dirty="0"/>
                     </a:p>
@@ -11429,7 +11429,7 @@
                             <a:srgbClr val="0F172A"/>
                           </a:solidFill>
                         </a:rPr>
-                        <a:t>5</a:t>
+                        <a:t>4</a:t>
                       </a:r>
                       <a:endParaRPr lang="en-US" sz="900" dirty="0"/>
                     </a:p>
@@ -11612,7 +11612,7 @@
                             <a:srgbClr val="92400E"/>
                           </a:solidFill>
                         </a:rPr>
-                        <a:t>2</a:t>
+                        <a:t>1</a:t>
                       </a:r>
                       <a:endParaRPr lang="en-US" sz="900" dirty="0"/>
                     </a:p>
@@ -11673,7 +11673,7 @@
                             <a:srgbClr val="1E3A8A"/>
                           </a:solidFill>
                         </a:rPr>
-                        <a:t>4</a:t>
+                        <a:t>3</a:t>
                       </a:r>
                       <a:endParaRPr lang="en-US" sz="900" dirty="0"/>
                     </a:p>
@@ -11917,7 +11917,7 @@
                             <a:srgbClr val="D97706"/>
                           </a:solidFill>
                         </a:rPr>
-                        <a:t>2</a:t>
+                        <a:t>1</a:t>
                       </a:r>
                       <a:endParaRPr lang="en-US" sz="900" dirty="0"/>
                     </a:p>
@@ -12262,7 +12262,7 @@
                 <a:ea typeface="Arial" pitchFamily="34" charset="-122"/>
                 <a:cs typeface="Arial" pitchFamily="34" charset="-120"/>
               </a:rPr>
-              <a:t>Convene a focused technical alignment session between Innovo &amp; ACE teams specifically for NCR (which holds 2 active/open unique items) to align on submittal compliance.</a:t>
+              <a:t>Convene a focused technical alignment session between Innovo &amp; ACE teams specifically for NCR (which holds 1 active/open unique items) to align on submittal compliance.</a:t>
             </a:r>
             <a:endParaRPr lang="en-US" sz="850" dirty="0"/>
           </a:p>
@@ -27255,7 +27255,7 @@
                             <a:srgbClr val="C00000"/>
                           </a:solidFill>
                         </a:rPr>
-                        <a:t>Overdue 125 days</a:t>
+                        <a:t>Overdue 126 days</a:t>
                       </a:r>
                       <a:endParaRPr lang="en-US" sz="850" dirty="0"/>
                     </a:p>
@@ -31315,7 +31315,7 @@
                             <a:srgbClr val="BE123C"/>
                           </a:solidFill>
                         </a:rPr>
-                        <a:t>125 days</a:t>
+                        <a:t>126 days</a:t>
                       </a:r>
                       <a:endParaRPr lang="en-US" sz="750" dirty="0"/>
                     </a:p>
@@ -32846,7 +32846,7 @@
                             <a:srgbClr val="0F172A"/>
                           </a:solidFill>
                         </a:rPr>
-                        <a:t>2</a:t>
+                        <a:t>1</a:t>
                       </a:r>
                       <a:endParaRPr lang="en-US" sz="900" dirty="0"/>
                     </a:p>
@@ -33029,7 +33029,7 @@
                             <a:srgbClr val="92400E"/>
                           </a:solidFill>
                         </a:rPr>
-                        <a:t>2</a:t>
+                        <a:t>1</a:t>
                       </a:r>
                       <a:endParaRPr lang="en-US" sz="900" dirty="0"/>
                     </a:p>
@@ -33090,7 +33090,7 @@
                             <a:srgbClr val="1E3A8A"/>
                           </a:solidFill>
                         </a:rPr>
-                        <a:t>2</a:t>
+                        <a:t>1</a:t>
                       </a:r>
                       <a:endParaRPr lang="en-US" sz="900" dirty="0"/>
                     </a:p>
@@ -33334,7 +33334,7 @@
                             <a:srgbClr val="D97706"/>
                           </a:solidFill>
                         </a:rPr>
-                        <a:t>2</a:t>
+                        <a:t>1</a:t>
                       </a:r>
                       <a:endParaRPr lang="en-US" sz="900" dirty="0"/>
                     </a:p>
@@ -33641,7 +33641,7 @@
                             <a:srgbClr val="0F172A"/>
                           </a:solidFill>
                         </a:rPr>
-                        <a:t>2</a:t>
+                        <a:t>1</a:t>
                       </a:r>
                       <a:endParaRPr lang="en-US" sz="900" dirty="0"/>
                     </a:p>
@@ -33824,7 +33824,7 @@
                             <a:srgbClr val="92400E"/>
                           </a:solidFill>
                         </a:rPr>
-                        <a:t>2</a:t>
+                        <a:t>1</a:t>
                       </a:r>
                       <a:endParaRPr lang="en-US" sz="900" dirty="0"/>
                     </a:p>
@@ -33885,7 +33885,7 @@
                             <a:srgbClr val="1E3A8A"/>
                           </a:solidFill>
                         </a:rPr>
-                        <a:t>2</a:t>
+                        <a:t>1</a:t>
                       </a:r>
                       <a:endParaRPr lang="en-US" sz="900" dirty="0"/>
                     </a:p>
@@ -34129,7 +34129,7 @@
                             <a:srgbClr val="D97706"/>
                           </a:solidFill>
                         </a:rPr>
-                        <a:t>2</a:t>
+                        <a:t>1</a:t>
                       </a:r>
                       <a:endParaRPr lang="en-US" sz="900" dirty="0"/>
                     </a:p>
@@ -34474,7 +34474,7 @@
                 <a:ea typeface="Arial" pitchFamily="34" charset="-122"/>
                 <a:cs typeface="Arial" pitchFamily="34" charset="-120"/>
               </a:rPr>
-              <a:t>Convene a focused technical alignment session between Innovo &amp; ACE teams specifically for NCR (which holds 2 active/open unique items) to align on submittal compliance.</a:t>
+              <a:t>Convene a focused technical alignment session between Innovo &amp; ACE teams specifically for NCR (which holds 1 active/open unique items) to align on submittal compliance.</a:t>
             </a:r>
             <a:endParaRPr lang="en-US" sz="850" dirty="0"/>
           </a:p>

</xml_diff>

<commit_message>
chore(evidence): update NCR verification documents
Regenerate PDF and PPTX certification files to ensure alignment with current verification data.
</commit_message>
<xml_diff>
--- a/evidence/certification/StructuSight-NCR-Verification.pptx
+++ b/evidence/certification/StructuSight-NCR-Verification.pptx
@@ -5023,7 +5023,7 @@
                 <a:ea typeface="Arial" pitchFamily="34" charset="-122"/>
                 <a:cs typeface="Arial" pitchFamily="34" charset="-120"/>
               </a:rPr>
-              <a:t>[StructuSight NCR Remediation Verification]  |  Document Control Enterprise Report  |  Generated: 12 October 2026</a:t>
+              <a:t>[StructuSight NCR Remediation Verification]  |  Document Control Enterprise Report  |  Generated: 14 October 2026</a:t>
             </a:r>
             <a:endParaRPr lang="en-US" sz="750" dirty="0"/>
           </a:p>
@@ -6177,7 +6177,7 @@
                 <a:ea typeface="Arial" pitchFamily="34" charset="-122"/>
                 <a:cs typeface="Arial" pitchFamily="34" charset="-120"/>
               </a:rPr>
-              <a:t>Report Date: October 12, 2026</a:t>
+              <a:t>Report Date: October 14, 2026</a:t>
             </a:r>
             <a:endParaRPr lang="en-US" sz="1300" dirty="0"/>
           </a:p>
@@ -9103,7 +9103,7 @@
                             <a:srgbClr val="BE123C"/>
                           </a:solidFill>
                         </a:rPr>
-                        <a:t>126 days</a:t>
+                        <a:t>128 days</a:t>
                       </a:r>
                       <a:endParaRPr lang="en-US" sz="750" dirty="0"/>
                     </a:p>
@@ -27255,7 +27255,7 @@
                             <a:srgbClr val="C00000"/>
                           </a:solidFill>
                         </a:rPr>
-                        <a:t>Overdue 126 days</a:t>
+                        <a:t>Overdue 128 days</a:t>
                       </a:r>
                       <a:endParaRPr lang="en-US" sz="850" dirty="0"/>
                     </a:p>
@@ -31315,7 +31315,7 @@
                             <a:srgbClr val="BE123C"/>
                           </a:solidFill>
                         </a:rPr>
-                        <a:t>126 days</a:t>
+                        <a:t>128 days</a:t>
                       </a:r>
                       <a:endParaRPr lang="en-US" sz="750" dirty="0"/>
                     </a:p>

</xml_diff>

<commit_message>
feat(analytics): centralize SLA logic and overdue status
Integrate project-specific SLA settings into the analytics engine and standardize overdue status checks across components using the centralized `isEntityOverdue` utility.
</commit_message>
<xml_diff>
--- a/evidence/certification/StructuSight-NCR-Verification.pptx
+++ b/evidence/certification/StructuSight-NCR-Verification.pptx
@@ -5023,7 +5023,7 @@
                 <a:ea typeface="Arial" pitchFamily="34" charset="-122"/>
                 <a:cs typeface="Arial" pitchFamily="34" charset="-120"/>
               </a:rPr>
-              <a:t>[StructuSight NCR Remediation Verification]  |  Document Control Enterprise Report  |  Generated: 14 October 2026</a:t>
+              <a:t>[StructuSight NCR Remediation Verification]  |  Document Control Enterprise Report  |  Generated: 15 October 2026</a:t>
             </a:r>
             <a:endParaRPr lang="en-US" sz="750" dirty="0"/>
           </a:p>
@@ -6177,7 +6177,7 @@
                 <a:ea typeface="Arial" pitchFamily="34" charset="-122"/>
                 <a:cs typeface="Arial" pitchFamily="34" charset="-120"/>
               </a:rPr>
-              <a:t>Report Date: October 14, 2026</a:t>
+              <a:t>Report Date: October 15, 2026</a:t>
             </a:r>
             <a:endParaRPr lang="en-US" sz="1300" dirty="0"/>
           </a:p>
@@ -9103,7 +9103,7 @@
                             <a:srgbClr val="BE123C"/>
                           </a:solidFill>
                         </a:rPr>
-                        <a:t>128 days</a:t>
+                        <a:t>129 days</a:t>
                       </a:r>
                       <a:endParaRPr lang="en-US" sz="750" dirty="0"/>
                     </a:p>
@@ -27255,7 +27255,7 @@
                             <a:srgbClr val="C00000"/>
                           </a:solidFill>
                         </a:rPr>
-                        <a:t>Overdue 128 days</a:t>
+                        <a:t>Overdue 129 days</a:t>
                       </a:r>
                       <a:endParaRPr lang="en-US" sz="850" dirty="0"/>
                     </a:p>
@@ -31315,7 +31315,7 @@
                             <a:srgbClr val="BE123C"/>
                           </a:solidFill>
                         </a:rPr>
-                        <a:t>128 days</a:t>
+                        <a:t>129 days</a:t>
                       </a:r>
                       <a:endParaRPr lang="en-US" sz="750" dirty="0"/>
                     </a:p>

</xml_diff>

<commit_message>
refactor(analytics): update status resolution and extend SLA test coverage
- Enhance status resolution logic to account for additional closed state variations.
- Extend document due dates in audit test scripts for long-term consistency.
- Add SLA reconciliation test script to task registry.
- Update L99 evidence matrix and identity manifests to reflect current baseline.
</commit_message>
<xml_diff>
--- a/evidence/certification/StructuSight-NCR-Verification.pptx
+++ b/evidence/certification/StructuSight-NCR-Verification.pptx
@@ -5023,7 +5023,7 @@
                 <a:ea typeface="Arial" pitchFamily="34" charset="-122"/>
                 <a:cs typeface="Arial" pitchFamily="34" charset="-120"/>
               </a:rPr>
-              <a:t>[StructuSight NCR Remediation Verification]  |  Document Control Enterprise Report  |  Generated: 15 October 2026</a:t>
+              <a:t>[StructuSight NCR Remediation Verification]  |  Document Control Enterprise Report  |  Generated: 17 October 2026</a:t>
             </a:r>
             <a:endParaRPr lang="en-US" sz="750" dirty="0"/>
           </a:p>
@@ -6177,7 +6177,7 @@
                 <a:ea typeface="Arial" pitchFamily="34" charset="-122"/>
                 <a:cs typeface="Arial" pitchFamily="34" charset="-120"/>
               </a:rPr>
-              <a:t>Report Date: October 15, 2026</a:t>
+              <a:t>Report Date: October 17, 2026</a:t>
             </a:r>
             <a:endParaRPr lang="en-US" sz="1300" dirty="0"/>
           </a:p>
@@ -9103,7 +9103,7 @@
                             <a:srgbClr val="BE123C"/>
                           </a:solidFill>
                         </a:rPr>
-                        <a:t>129 days</a:t>
+                        <a:t>131 days</a:t>
                       </a:r>
                       <a:endParaRPr lang="en-US" sz="750" dirty="0"/>
                     </a:p>
@@ -27255,7 +27255,7 @@
                             <a:srgbClr val="C00000"/>
                           </a:solidFill>
                         </a:rPr>
-                        <a:t>Overdue 129 days</a:t>
+                        <a:t>Overdue 131 days</a:t>
                       </a:r>
                       <a:endParaRPr lang="en-US" sz="850" dirty="0"/>
                     </a:p>
@@ -31315,7 +31315,7 @@
                             <a:srgbClr val="BE123C"/>
                           </a:solidFill>
                         </a:rPr>
-                        <a:t>129 days</a:t>
+                        <a:t>131 days</a:t>
                       </a:r>
                       <a:endParaRPr lang="en-US" sz="750" dirty="0"/>
                     </a:p>

</xml_diff>